<commit_message>
generacion ultima version funcional
</commit_message>
<xml_diff>
--- a/src/main/resources/static/plantillas/plantilla formateada.pptx
+++ b/src/main/resources/static/plantillas/plantilla formateada.pptx
@@ -42,7 +42,7 @@
         <p:spPr>
           <a:xfrm>
             <a:off x="518040" y="309960"/>
-            <a:ext cx="9324360" cy="1295280"/>
+            <a:ext cx="9324000" cy="1294920"/>
           </a:xfrm>
           <a:prstGeom prst="rect">
             <a:avLst/>
@@ -145,7 +145,7 @@
         <p:txBody>
           <a:bodyPr/>
           <a:p>
-            <a:fld id="{F93BB04B-39F4-415F-BE82-09FE7B2AD8F7}" type="slidenum">
+            <a:fld id="{2BED0C87-2546-4890-BB8A-ADE325B35F0D}" type="slidenum">
               <a:t>&lt;#&gt;</a:t>
             </a:fld>
           </a:p>
@@ -214,7 +214,7 @@
         <p:spPr>
           <a:xfrm>
             <a:off x="518040" y="309960"/>
-            <a:ext cx="9324360" cy="1295280"/>
+            <a:ext cx="9324000" cy="1294920"/>
           </a:xfrm>
           <a:prstGeom prst="rect">
             <a:avLst/>
@@ -265,7 +265,7 @@
         <p:spPr>
           <a:xfrm>
             <a:off x="3432960" y="7203960"/>
-            <a:ext cx="3495240" cy="411120"/>
+            <a:ext cx="3494880" cy="410760"/>
           </a:xfrm>
           <a:prstGeom prst="rect">
             <a:avLst/>
@@ -340,7 +340,7 @@
         <p:spPr>
           <a:xfrm>
             <a:off x="7319160" y="7203960"/>
-            <a:ext cx="2329200" cy="411120"/>
+            <a:ext cx="2328840" cy="410760"/>
           </a:xfrm>
           <a:prstGeom prst="rect">
             <a:avLst/>
@@ -384,7 +384,7 @@
                 <a:tab algn="l" pos="0"/>
               </a:tabLst>
             </a:pPr>
-            <a:fld id="{0194B007-6521-4072-BD6D-E9F694666052}" type="slidenum">
+            <a:fld id="{388EE8C0-B727-473E-AF5F-BEC87BA08D99}" type="slidenum">
               <a:rPr b="0" lang="es-ES_tradnl" sz="1360" strike="noStrike" u="none">
                 <a:solidFill>
                   <a:schemeClr val="dk1">
@@ -419,7 +419,7 @@
         <p:spPr>
           <a:xfrm>
             <a:off x="712440" y="7203960"/>
-            <a:ext cx="2329200" cy="411120"/>
+            <a:ext cx="2328840" cy="410760"/>
           </a:xfrm>
           <a:prstGeom prst="rect">
             <a:avLst/>
@@ -747,7 +747,7 @@
         <p:spPr>
           <a:xfrm>
             <a:off x="3429000" y="1852560"/>
-            <a:ext cx="3502800" cy="4064760"/>
+            <a:ext cx="3502440" cy="4064400"/>
           </a:xfrm>
           <a:prstGeom prst="rect">
             <a:avLst/>
@@ -770,7 +770,7 @@
         <p:spPr>
           <a:xfrm>
             <a:off x="0" y="0"/>
-            <a:ext cx="10359000" cy="7769880"/>
+            <a:ext cx="10358640" cy="7769520"/>
           </a:xfrm>
           <a:prstGeom prst="rect">
             <a:avLst/>
@@ -789,7 +789,7 @@
         <p:spPr>
           <a:xfrm>
             <a:off x="735120" y="867600"/>
-            <a:ext cx="8803440" cy="6172920"/>
+            <a:ext cx="8803080" cy="6172560"/>
           </a:xfrm>
           <a:prstGeom prst="rect">
             <a:avLst/>
@@ -837,7 +837,7 @@
         <p:spPr>
           <a:xfrm>
             <a:off x="3188880" y="6262920"/>
-            <a:ext cx="4055760" cy="664560"/>
+            <a:ext cx="4055400" cy="664200"/>
           </a:xfrm>
           <a:prstGeom prst="rect">
             <a:avLst/>
@@ -892,7 +892,7 @@
         <p:spPr>
           <a:xfrm>
             <a:off x="3002400" y="1030680"/>
-            <a:ext cx="4429080" cy="1121400"/>
+            <a:ext cx="4428720" cy="1121040"/>
           </a:xfrm>
           <a:prstGeom prst="rect">
             <a:avLst/>
@@ -911,7 +911,7 @@
         <p:spPr>
           <a:xfrm>
             <a:off x="1089720" y="2400120"/>
-            <a:ext cx="7802280" cy="455400"/>
+            <a:ext cx="7801920" cy="455400"/>
           </a:xfrm>
           <a:prstGeom prst="rect">
             <a:avLst/>
@@ -1014,12 +1014,12 @@
               </a:rPr>
               <a:t>ta).: </a:t>
             </a:r>
-            <a:endParaRPr b="1" lang="es-MX" sz="2400" strike="noStrike" u="none">
-              <a:solidFill>
-                <a:srgbClr val="000000"/>
-              </a:solidFill>
-              <a:uFillTx/>
-              <a:latin typeface="Times New Roman"/>
+            <a:endParaRPr b="0" lang="es-MX" sz="2400" strike="noStrike" u="none">
+              <a:solidFill>
+                <a:srgbClr val="000000"/>
+              </a:solidFill>
+              <a:uFillTx/>
+              <a:latin typeface="Arial"/>
             </a:endParaRPr>
           </a:p>
         </p:txBody>
@@ -1033,7 +1033,7 @@
         <p:spPr>
           <a:xfrm>
             <a:off x="999360" y="3013200"/>
-            <a:ext cx="8462520" cy="394560"/>
+            <a:ext cx="8462160" cy="394560"/>
           </a:xfrm>
           <a:prstGeom prst="rect">
             <a:avLst/>
@@ -1081,12 +1081,12 @@
               </a:rPr>
               <a:t>:</a:t>
             </a:r>
-            <a:endParaRPr b="1" lang="es-MX" sz="2000" strike="noStrike" u="none">
-              <a:solidFill>
-                <a:srgbClr val="000000"/>
-              </a:solidFill>
-              <a:uFillTx/>
-              <a:latin typeface="Times New Roman"/>
+            <a:endParaRPr b="0" lang="es-MX" sz="2000" strike="noStrike" u="none">
+              <a:solidFill>
+                <a:srgbClr val="000000"/>
+              </a:solidFill>
+              <a:uFillTx/>
+              <a:latin typeface="Arial"/>
             </a:endParaRPr>
           </a:p>
         </p:txBody>
@@ -1100,7 +1100,7 @@
         <p:spPr>
           <a:xfrm>
             <a:off x="1089720" y="5664600"/>
-            <a:ext cx="2994480" cy="366840"/>
+            <a:ext cx="2994120" cy="366480"/>
           </a:xfrm>
           <a:prstGeom prst="rect">
             <a:avLst/>
@@ -1146,7 +1146,7 @@
         <p:spPr>
           <a:xfrm>
             <a:off x="5617080" y="5936760"/>
-            <a:ext cx="2892960" cy="366840"/>
+            <a:ext cx="2892600" cy="366480"/>
           </a:xfrm>
           <a:prstGeom prst="rect">
             <a:avLst/>
@@ -1192,7 +1192,7 @@
         <p:spPr>
           <a:xfrm>
             <a:off x="5747400" y="6252120"/>
-            <a:ext cx="3010320" cy="13320"/>
+            <a:ext cx="3010680" cy="13680"/>
           </a:xfrm>
           <a:prstGeom prst="straightConnector1">
             <a:avLst/>
@@ -1214,15 +1214,15 @@
         <p:spPr>
           <a:xfrm>
             <a:off x="3837600" y="802440"/>
-            <a:ext cx="717840" cy="178920"/>
+            <a:ext cx="717480" cy="178560"/>
           </a:xfrm>
           <a:custGeom>
             <a:avLst/>
             <a:gdLst>
-              <a:gd name="textAreaLeft" fmla="*/ 0 w 717840"/>
-              <a:gd name="textAreaRight" fmla="*/ 720360 w 717840"/>
-              <a:gd name="textAreaTop" fmla="*/ 0 h 178920"/>
-              <a:gd name="textAreaBottom" fmla="*/ 181440 h 178920"/>
+              <a:gd name="textAreaLeft" fmla="*/ 0 w 717480"/>
+              <a:gd name="textAreaRight" fmla="*/ 720360 w 717480"/>
+              <a:gd name="textAreaTop" fmla="*/ 0 h 178560"/>
+              <a:gd name="textAreaBottom" fmla="*/ 181440 h 178560"/>
             </a:gdLst>
             <a:ahLst/>
             <a:rect l="textAreaLeft" t="textAreaTop" r="textAreaRight" b="textAreaBottom"/>
@@ -1324,7 +1324,7 @@
         <p:spPr>
           <a:xfrm>
             <a:off x="0" y="0"/>
-            <a:ext cx="483480" cy="7759080"/>
+            <a:ext cx="483120" cy="7758720"/>
           </a:xfrm>
           <a:prstGeom prst="rect">
             <a:avLst/>
@@ -1375,7 +1375,7 @@
         <p:spPr>
           <a:xfrm>
             <a:off x="0" y="0"/>
-            <a:ext cx="10360800" cy="524520"/>
+            <a:ext cx="10360440" cy="524160"/>
           </a:xfrm>
           <a:prstGeom prst="rect">
             <a:avLst/>
@@ -1426,7 +1426,7 @@
         <p:spPr>
           <a:xfrm>
             <a:off x="9878400" y="10800"/>
-            <a:ext cx="482400" cy="7759080"/>
+            <a:ext cx="482040" cy="7758720"/>
           </a:xfrm>
           <a:prstGeom prst="rect">
             <a:avLst/>
@@ -1477,7 +1477,7 @@
         <p:spPr>
           <a:xfrm>
             <a:off x="0" y="7246080"/>
-            <a:ext cx="10361880" cy="523800"/>
+            <a:ext cx="10361520" cy="523440"/>
           </a:xfrm>
           <a:prstGeom prst="rect">
             <a:avLst/>
@@ -1528,7 +1528,7 @@
         <p:spPr>
           <a:xfrm flipV="1">
             <a:off x="701640" y="7039800"/>
-            <a:ext cx="8965080" cy="5400"/>
+            <a:ext cx="8965440" cy="5760"/>
           </a:xfrm>
           <a:prstGeom prst="straightConnector1">
             <a:avLst/>
@@ -1550,7 +1550,7 @@
         <p:spPr>
           <a:xfrm>
             <a:off x="701640" y="720360"/>
-            <a:ext cx="8965080" cy="2520"/>
+            <a:ext cx="8965440" cy="2880"/>
           </a:xfrm>
           <a:prstGeom prst="straightConnector1">
             <a:avLst/>
@@ -1572,7 +1572,7 @@
         <p:spPr>
           <a:xfrm flipV="1">
             <a:off x="701640" y="720360"/>
-            <a:ext cx="2520" cy="6321960"/>
+            <a:ext cx="2880" cy="6322320"/>
           </a:xfrm>
           <a:prstGeom prst="straightConnector1">
             <a:avLst/>
@@ -1594,7 +1594,7 @@
         <p:spPr>
           <a:xfrm>
             <a:off x="1203840" y="6262920"/>
-            <a:ext cx="3142080" cy="959040"/>
+            <a:ext cx="3141720" cy="959040"/>
           </a:xfrm>
           <a:prstGeom prst="rect">
             <a:avLst/>
@@ -1631,12 +1631,12 @@
               </a:rPr>
               <a:t>Margarita Vásquez Zúñiga       Gerente  Operaciones            </a:t>
             </a:r>
-            <a:endParaRPr b="1" lang="es-MX" sz="1300" strike="noStrike" u="none">
-              <a:solidFill>
-                <a:srgbClr val="000000"/>
-              </a:solidFill>
-              <a:uFillTx/>
-              <a:latin typeface="Times New Roman"/>
+            <a:endParaRPr b="0" lang="es-MX" sz="1300" strike="noStrike" u="none">
+              <a:solidFill>
+                <a:srgbClr val="000000"/>
+              </a:solidFill>
+              <a:uFillTx/>
+              <a:latin typeface="Arial"/>
             </a:endParaRPr>
           </a:p>
           <a:p>
@@ -1667,12 +1667,12 @@
               </a:rPr>
               <a:t>E-volution Capacitación Ltda.</a:t>
             </a:r>
-            <a:endParaRPr b="1" lang="es-MX" sz="1300" strike="noStrike" u="none">
-              <a:solidFill>
-                <a:srgbClr val="000000"/>
-              </a:solidFill>
-              <a:uFillTx/>
-              <a:latin typeface="Times New Roman"/>
+            <a:endParaRPr b="0" lang="es-MX" sz="1300" strike="noStrike" u="none">
+              <a:solidFill>
+                <a:srgbClr val="000000"/>
+              </a:solidFill>
+              <a:uFillTx/>
+              <a:latin typeface="Arial"/>
             </a:endParaRPr>
           </a:p>
           <a:p>
@@ -1681,12 +1681,12 @@
                 <a:spcPct val="100000"/>
               </a:lnSpc>
             </a:pPr>
-            <a:endParaRPr b="1" lang="es-MX" sz="1800" strike="noStrike" u="none">
-              <a:solidFill>
-                <a:srgbClr val="000000"/>
-              </a:solidFill>
-              <a:uFillTx/>
-              <a:latin typeface="Times New Roman"/>
+            <a:endParaRPr b="0" lang="es-MX" sz="1800" strike="noStrike" u="none">
+              <a:solidFill>
+                <a:srgbClr val="000000"/>
+              </a:solidFill>
+              <a:uFillTx/>
+              <a:latin typeface="Arial"/>
             </a:endParaRPr>
           </a:p>
         </p:txBody>
@@ -1700,7 +1700,7 @@
         <p:spPr>
           <a:xfrm>
             <a:off x="5747760" y="6262920"/>
-            <a:ext cx="3144240" cy="959040"/>
+            <a:ext cx="3143880" cy="959040"/>
           </a:xfrm>
           <a:prstGeom prst="rect">
             <a:avLst/>
@@ -1737,12 +1737,12 @@
               </a:rPr>
               <a:t>Gabriel Parra Fuentes </a:t>
             </a:r>
-            <a:endParaRPr b="1" lang="es-MX" sz="1300" strike="noStrike" u="none">
-              <a:solidFill>
-                <a:srgbClr val="000000"/>
-              </a:solidFill>
-              <a:uFillTx/>
-              <a:latin typeface="Times New Roman"/>
+            <a:endParaRPr b="0" lang="es-MX" sz="1300" strike="noStrike" u="none">
+              <a:solidFill>
+                <a:srgbClr val="000000"/>
+              </a:solidFill>
+              <a:uFillTx/>
+              <a:latin typeface="Arial"/>
             </a:endParaRPr>
           </a:p>
           <a:p>
@@ -1762,12 +1762,12 @@
               </a:rPr>
               <a:t>Gerente  General</a:t>
             </a:r>
-            <a:endParaRPr b="1" lang="es-MX" sz="1300" strike="noStrike" u="none">
-              <a:solidFill>
-                <a:srgbClr val="000000"/>
-              </a:solidFill>
-              <a:uFillTx/>
-              <a:latin typeface="Times New Roman"/>
+            <a:endParaRPr b="0" lang="es-MX" sz="1300" strike="noStrike" u="none">
+              <a:solidFill>
+                <a:srgbClr val="000000"/>
+              </a:solidFill>
+              <a:uFillTx/>
+              <a:latin typeface="Arial"/>
             </a:endParaRPr>
           </a:p>
           <a:p>
@@ -1787,12 +1787,12 @@
               </a:rPr>
               <a:t>E-volution Capacitación Ltda.</a:t>
             </a:r>
-            <a:endParaRPr b="1" lang="es-MX" sz="1300" strike="noStrike" u="none">
-              <a:solidFill>
-                <a:srgbClr val="000000"/>
-              </a:solidFill>
-              <a:uFillTx/>
-              <a:latin typeface="Times New Roman"/>
+            <a:endParaRPr b="0" lang="es-MX" sz="1300" strike="noStrike" u="none">
+              <a:solidFill>
+                <a:srgbClr val="000000"/>
+              </a:solidFill>
+              <a:uFillTx/>
+              <a:latin typeface="Arial"/>
             </a:endParaRPr>
           </a:p>
           <a:p>
@@ -1801,12 +1801,12 @@
                 <a:spcPct val="100000"/>
               </a:lnSpc>
             </a:pPr>
-            <a:endParaRPr b="1" lang="es-MX" sz="1800" strike="noStrike" u="none">
-              <a:solidFill>
-                <a:srgbClr val="000000"/>
-              </a:solidFill>
-              <a:uFillTx/>
-              <a:latin typeface="Times New Roman"/>
+            <a:endParaRPr b="0" lang="es-MX" sz="1800" strike="noStrike" u="none">
+              <a:solidFill>
+                <a:srgbClr val="000000"/>
+              </a:solidFill>
+              <a:uFillTx/>
+              <a:latin typeface="Arial"/>
             </a:endParaRPr>
           </a:p>
         </p:txBody>
@@ -1820,7 +1820,7 @@
         <p:spPr>
           <a:xfrm>
             <a:off x="1772640" y="4417200"/>
-            <a:ext cx="5658840" cy="1461240"/>
+            <a:ext cx="5658480" cy="1461240"/>
           </a:xfrm>
           <a:prstGeom prst="rect">
             <a:avLst/>
@@ -1868,12 +1868,12 @@
               </a:rPr>
               <a:t>8 Hrs.</a:t>
             </a:r>
-            <a:endParaRPr b="1" lang="es-MX" sz="2000" strike="noStrike" u="none">
-              <a:solidFill>
-                <a:srgbClr val="000000"/>
-              </a:solidFill>
-              <a:uFillTx/>
-              <a:latin typeface="Times New Roman"/>
+            <a:endParaRPr b="0" lang="es-MX" sz="2000" strike="noStrike" u="none">
+              <a:solidFill>
+                <a:srgbClr val="000000"/>
+              </a:solidFill>
+              <a:uFillTx/>
+              <a:latin typeface="Arial"/>
             </a:endParaRPr>
           </a:p>
           <a:p>
@@ -1904,12 +1904,12 @@
               </a:rPr>
               <a:t>el día 26 de febrero 2020</a:t>
             </a:r>
-            <a:endParaRPr b="1" lang="es-MX" sz="2000" strike="noStrike" u="none">
-              <a:solidFill>
-                <a:srgbClr val="000000"/>
-              </a:solidFill>
-              <a:uFillTx/>
-              <a:latin typeface="Times New Roman"/>
+            <a:endParaRPr b="0" lang="es-MX" sz="2000" strike="noStrike" u="none">
+              <a:solidFill>
+                <a:srgbClr val="000000"/>
+              </a:solidFill>
+              <a:uFillTx/>
+              <a:latin typeface="Arial"/>
             </a:endParaRPr>
           </a:p>
         </p:txBody>
@@ -1923,7 +1923,7 @@
         <p:spPr>
           <a:xfrm>
             <a:off x="1398960" y="6262920"/>
-            <a:ext cx="2662200" cy="2520"/>
+            <a:ext cx="2662560" cy="2880"/>
           </a:xfrm>
           <a:prstGeom prst="straightConnector1">
             <a:avLst/>
@@ -1945,7 +1945,7 @@
         <p:spPr>
           <a:xfrm>
             <a:off x="3429360" y="2400120"/>
-            <a:ext cx="5209920" cy="513720"/>
+            <a:ext cx="5209560" cy="516600"/>
           </a:xfrm>
           <a:prstGeom prst="rect">
             <a:avLst/>
@@ -1968,12 +1968,22 @@
             <a:spAutoFit/>
           </a:bodyPr>
           <a:p>
+            <a:r>
+              <a:rPr b="1" lang="es-MX" sz="2800" strike="noStrike" u="none">
+                <a:solidFill>
+                  <a:srgbClr val="000000"/>
+                </a:solidFill>
+                <a:uFillTx/>
+                <a:latin typeface="Arial"/>
+              </a:rPr>
+              <a:t>${nombreAsistente}</a:t>
+            </a:r>
             <a:endParaRPr b="1" lang="es-MX" sz="2800" strike="noStrike" u="none">
               <a:solidFill>
                 <a:srgbClr val="000000"/>
               </a:solidFill>
               <a:uFillTx/>
-              <a:latin typeface="Cantarell Extra Bold"/>
+              <a:latin typeface="Arial"/>
               <a:ea typeface="DejaVu Sans"/>
             </a:endParaRPr>
           </a:p>
@@ -1988,7 +1998,7 @@
         <p:spPr>
           <a:xfrm>
             <a:off x="5581440" y="1951560"/>
-            <a:ext cx="330120" cy="366840"/>
+            <a:ext cx="329760" cy="366480"/>
           </a:xfrm>
           <a:prstGeom prst="rect">
             <a:avLst/>
@@ -2040,7 +2050,7 @@
         <p:spPr>
           <a:xfrm>
             <a:off x="7398360" y="987480"/>
-            <a:ext cx="2109600" cy="522360"/>
+            <a:ext cx="2109240" cy="522000"/>
           </a:xfrm>
           <a:prstGeom prst="rect">
             <a:avLst/>
@@ -2063,7 +2073,7 @@
         <p:spPr>
           <a:xfrm>
             <a:off x="991440" y="881280"/>
-            <a:ext cx="1312200" cy="970560"/>
+            <a:ext cx="1311840" cy="970200"/>
           </a:xfrm>
           <a:prstGeom prst="rect">
             <a:avLst/>
@@ -2082,7 +2092,7 @@
         <p:spPr>
           <a:xfrm>
             <a:off x="1980000" y="3600000"/>
-            <a:ext cx="5939280" cy="719280"/>
+            <a:ext cx="5938920" cy="718920"/>
           </a:xfrm>
           <a:prstGeom prst="rect">
             <a:avLst/>
@@ -2107,17 +2117,22 @@
             <a:noAutofit/>
           </a:bodyPr>
           <a:p>
-            <a:pPr>
-              <a:lnSpc>
-                <a:spcPct val="100000"/>
-              </a:lnSpc>
-            </a:pPr>
+            <a:r>
+              <a:rPr b="1" lang="es-MX" sz="1800" strike="noStrike" u="none">
+                <a:solidFill>
+                  <a:srgbClr val="000000"/>
+                </a:solidFill>
+                <a:uFillTx/>
+                <a:latin typeface="Sheriff"/>
+              </a:rPr>
+              <a:t>${nombreCurso}</a:t>
+            </a:r>
             <a:endParaRPr b="0" lang="es-MX" sz="1800" strike="noStrike" u="none">
               <a:solidFill>
                 <a:srgbClr val="000000"/>
               </a:solidFill>
               <a:uFillTx/>
-              <a:latin typeface="Arial"/>
+              <a:latin typeface="Sheriff"/>
               <a:ea typeface="DejaVu Sans"/>
             </a:endParaRPr>
           </a:p>

</xml_diff>